<commit_message>
3-minute deck refreshed: live numbers (12 companies, 36 contracts, A$87B, 12/12 verified) and the Canva valuation
Co-Authored-By: Claude Opus 5.5 (1M context) <noreply@anthropic.com>
</commit_message>
<xml_diff>
--- a/docs/pitch/BlockID-Startup-Passport-3min.pptx
+++ b/docs/pitch/BlockID-Startup-Passport-3min.pptx
@@ -772,7 +772,7 @@
           <a:p>
             <a:r>
               <a:rPr lang="en-US" dirty="0"/>
-              <a:t>[1:15–1:40] The AI only suggests scores. A fixed, public formula turns seven weighted dimensions into a grade and a valuation range, and any claim without a fetched source is dropped. For Airwallex it found eight real competitors and graded it C.</a:t>
+              <a:t>[1:15–1:40] The AI only suggests scores. A fixed, public formula turns seven weighted dimensions into a grade and a valuation range, and any claim without a fetched source is dropped. For Canva it found nine real competitors, a cited ARR of A$6 billion and an implied multiple from its last round.</a:t>
             </a:r>
             <a:endParaRPr lang="en-US" dirty="0"/>
           </a:p>
@@ -1036,7 +1036,7 @@
           <a:p>
             <a:r>
               <a:rPr lang="en-US" dirty="0"/>
-              <a:t>[2:25–3:00] This is live today: seven real companies, twenty-one token contracts on three chains, A$444M of valuation on-chain, every hash verified. Our customers are founders, accelerators and licensed intermediaries who issue and administer startup equity. Scan the code and try it at eth.blockid.au — we're looking for pilot startups and licensed partners. Thank you.</a:t>
+              <a:t>[2:25–3:00] This is live today: twelve real companies, thirty-six token contracts on three chains, A$87 billion of valuation on-chain, every hash verified. Our full demo run took Canva from its website to a share register on three chains, a new round, a dividend and a shareholder transfer in eleven minutes. Our customers are founders, accelerators and licensed intermediaries who issue and administer startup equity. Scan the code and try it at eth.blockid.au — we're looking for pilot startups and licensed partners. Thank you.</a:t>
             </a:r>
             <a:endParaRPr lang="en-US" dirty="0"/>
           </a:p>
@@ -5016,11 +5016,11 @@
         <p:spPr>
           <a:xfrm>
             <a:off x="457200" y="1600200"/>
-            <a:ext cx="7726680" cy="3919664"/>
+            <a:ext cx="7726680" cy="4174172"/>
           </a:xfrm>
           <a:prstGeom prst="roundRect">
             <a:avLst>
-              <a:gd name="adj" fmla="val 1866"/>
+              <a:gd name="adj" fmla="val 1752"/>
             </a:avLst>
           </a:prstGeom>
           <a:solidFill>
@@ -5058,7 +5058,7 @@
         <p:spPr>
           <a:xfrm>
             <a:off x="502920" y="1645920"/>
-            <a:ext cx="7635240" cy="3828224"/>
+            <a:ext cx="7635240" cy="4082732"/>
           </a:xfrm>
           <a:prstGeom prst="rect">
             <a:avLst/>
@@ -5381,7 +5381,7 @@
                 <a:ea typeface="Calibri" pitchFamily="34" charset="-122"/>
                 <a:cs typeface="Calibri" pitchFamily="34" charset="-120"/>
               </a:rPr>
-              <a:t>Airwallex → 8 competitors found (Wise, Revolut, OFX…) → SVI 54.5 · grade C</a:t>
+              <a:t>Canva: 9 competitors · ARR A$6B cited · 10.5x implied · A$64B mid</a:t>
             </a:r>
             <a:endParaRPr lang="en-US" sz="1300" dirty="0"/>
           </a:p>
@@ -5545,11 +5545,11 @@
         <p:spPr>
           <a:xfrm>
             <a:off x="457200" y="1600200"/>
-            <a:ext cx="5623560" cy="3414554"/>
+            <a:ext cx="5623560" cy="2415699"/>
           </a:xfrm>
           <a:prstGeom prst="roundRect">
             <a:avLst>
-              <a:gd name="adj" fmla="val 2142"/>
+              <a:gd name="adj" fmla="val 3028"/>
             </a:avLst>
           </a:prstGeom>
           <a:solidFill>
@@ -5587,7 +5587,7 @@
         <p:spPr>
           <a:xfrm>
             <a:off x="502920" y="1645920"/>
-            <a:ext cx="5532120" cy="3323114"/>
+            <a:ext cx="5532120" cy="2324259"/>
           </a:xfrm>
           <a:prstGeom prst="rect">
             <a:avLst/>
@@ -6699,7 +6699,7 @@
                 <a:ea typeface="Arial" pitchFamily="34" charset="-122"/>
                 <a:cs typeface="Arial" pitchFamily="34" charset="-120"/>
               </a:rPr>
-              <a:t>7</a:t>
+              <a:t>12</a:t>
             </a:r>
             <a:endParaRPr lang="en-US" sz="3000" dirty="0"/>
           </a:p>
@@ -6804,7 +6804,7 @@
                 <a:ea typeface="Arial" pitchFamily="34" charset="-122"/>
                 <a:cs typeface="Arial" pitchFamily="34" charset="-120"/>
               </a:rPr>
-              <a:t>21</a:t>
+              <a:t>36</a:t>
             </a:r>
             <a:endParaRPr lang="en-US" sz="3000" dirty="0"/>
           </a:p>
@@ -6909,7 +6909,7 @@
                 <a:ea typeface="Arial" pitchFamily="34" charset="-122"/>
                 <a:cs typeface="Arial" pitchFamily="34" charset="-120"/>
               </a:rPr>
-              <a:t>A$444M</a:t>
+              <a:t>A$87B</a:t>
             </a:r>
             <a:endParaRPr lang="en-US" sz="3000" dirty="0"/>
           </a:p>
@@ -7014,7 +7014,7 @@
                 <a:ea typeface="Arial" pitchFamily="34" charset="-122"/>
                 <a:cs typeface="Arial" pitchFamily="34" charset="-120"/>
               </a:rPr>
-              <a:t>100%</a:t>
+              <a:t>12/12</a:t>
             </a:r>
             <a:endParaRPr lang="en-US" sz="3000" dirty="0"/>
           </a:p>

</xml_diff>

<commit_message>
Contact: info@blockid.au and LinkedIn (linkedin.com/in/dovanlong) in the site footer and on the closing slide of both decks
Co-Authored-By: Claude Opus 5.5 <noreply@anthropic.com>
</commit_message>
<xml_diff>
--- a/docs/pitch/BlockID-Startup-Passport-3min.pptx
+++ b/docs/pitch/BlockID-Startup-Passport-3min.pptx
@@ -7654,8 +7654,8 @@
         </p:nvSpPr>
         <p:spPr>
           <a:xfrm>
-            <a:off x="8686800" y="5532120"/>
-            <a:ext cx="2880360" cy="320040"/>
+            <a:off x="8686800" y="5440680"/>
+            <a:ext cx="2880360" cy="292608"/>
           </a:xfrm>
           <a:prstGeom prst="rect">
             <a:avLst/>
@@ -7688,6 +7688,52 @@
       <p:sp>
         <p:nvSpPr>
           <p:cNvPr id="35" name="Text 31"/>
+          <p:cNvSpPr txBox="1"/>
+          <p:nvPr/>
+        </p:nvSpPr>
+        <p:spPr>
+          <a:xfrm>
+            <a:off x="8686800" y="5733288"/>
+            <a:ext cx="2880360" cy="292608"/>
+          </a:xfrm>
+          <a:prstGeom prst="rect">
+            <a:avLst/>
+          </a:prstGeom>
+          <a:noFill/>
+          <a:ln/>
+        </p:spPr>
+        <p:txBody>
+          <a:bodyPr wrap="square" lIns="0" tIns="0" rIns="0" bIns="0" rtlCol="0" anchor="ctr"/>
+          <a:lstStyle/>
+          <a:p>
+            <a:pPr algn="ctr" indent="0" marL="0">
+              <a:buNone/>
+            </a:pPr>
+            <a:r>
+              <a:rPr lang="en-US" sz="1200" b="1" u="sng" dirty="0">
+                <a:solidFill>
+                  <a:srgbClr val="22A07F"/>
+                </a:solidFill>
+                <a:latin typeface="Calibri" pitchFamily="34" charset="0"/>
+                <a:ea typeface="Calibri" pitchFamily="34" charset="-122"/>
+                <a:cs typeface="Calibri" pitchFamily="34" charset="-120"/>
+                <a:hlinkClick r:id="rId3" invalidUrl="" action="" tgtFrame="" tooltip="Long Do on LinkedIn" history="1" highlightClick="0" endSnd="0">
+                  <a:extLst>
+                    <a:ext uri="{A12FA001-AC4F-418D-AE19-62706E023703}">
+                      <ahyp:hlinkClr xmlns:ahyp="http://schemas.microsoft.com/office/drawing/2018/hyperlinkcolor" val="tx"/>
+                    </a:ext>
+                  </a:extLst>
+                </a:hlinkClick>
+              </a:rPr>
+              <a:t>linkedin.com/in/dovanlong</a:t>
+            </a:r>
+            <a:endParaRPr lang="en-US" sz="1200" dirty="0"/>
+          </a:p>
+        </p:txBody>
+      </p:sp>
+      <p:sp>
+        <p:nvSpPr>
+          <p:cNvPr id="36" name="Text 32"/>
           <p:cNvSpPr txBox="1"/>
           <p:nvPr/>
         </p:nvSpPr>

</xml_diff>

<commit_message>
Startup Passport decks: LinkedIn QR card for the founder on the closing slides
Co-Authored-By: Claude Opus 5.5 <noreply@anthropic.com>
</commit_message>
<xml_diff>
--- a/docs/pitch/BlockID-Startup-Passport-3min.pptx
+++ b/docs/pitch/BlockID-Startup-Passport-3min.pptx
@@ -7521,8 +7521,8 @@
         </p:blipFill>
         <p:spPr>
           <a:xfrm>
-            <a:off x="9253728" y="1874520"/>
-            <a:ext cx="1737360" cy="1737360"/>
+            <a:off x="8732520" y="1783080"/>
+            <a:ext cx="1280160" cy="1280160"/>
           </a:xfrm>
           <a:prstGeom prst="rect">
             <a:avLst/>
@@ -7537,8 +7537,8 @@
         </p:nvSpPr>
         <p:spPr>
           <a:xfrm>
-            <a:off x="8686800" y="3749040"/>
-            <a:ext cx="2880360" cy="411480"/>
+            <a:off x="8732520" y="3108960"/>
+            <a:ext cx="1280160" cy="256032"/>
           </a:xfrm>
           <a:prstGeom prst="rect">
             <a:avLst/>
@@ -7554,7 +7554,187 @@
               <a:buNone/>
             </a:pPr>
             <a:r>
-              <a:rPr lang="en-US" sz="2000" b="1" dirty="0">
+              <a:rPr lang="en-US" sz="1050" b="1" dirty="0">
+                <a:solidFill>
+                  <a:srgbClr val="22A07F"/>
+                </a:solidFill>
+                <a:latin typeface="Calibri" pitchFamily="34" charset="0"/>
+                <a:ea typeface="Calibri" pitchFamily="34" charset="-122"/>
+                <a:cs typeface="Calibri" pitchFamily="34" charset="-120"/>
+              </a:rPr>
+              <a:t>App Demo</a:t>
+            </a:r>
+            <a:endParaRPr lang="en-US" sz="1050" dirty="0"/>
+          </a:p>
+        </p:txBody>
+      </p:sp>
+      <p:sp>
+        <p:nvSpPr>
+          <p:cNvPr id="32" name="Text 28"/>
+          <p:cNvSpPr txBox="1"/>
+          <p:nvPr/>
+        </p:nvSpPr>
+        <p:spPr>
+          <a:xfrm>
+            <a:off x="8732520" y="3337560"/>
+            <a:ext cx="1280160" cy="228600"/>
+          </a:xfrm>
+          <a:prstGeom prst="rect">
+            <a:avLst/>
+          </a:prstGeom>
+          <a:noFill/>
+          <a:ln/>
+        </p:spPr>
+        <p:txBody>
+          <a:bodyPr wrap="square" lIns="0" tIns="0" rIns="0" bIns="0" rtlCol="0" anchor="ctr"/>
+          <a:lstStyle/>
+          <a:p>
+            <a:pPr algn="ctr" indent="0" marL="0">
+              <a:buNone/>
+            </a:pPr>
+            <a:r>
+              <a:rPr lang="en-US" sz="850" dirty="0">
+                <a:solidFill>
+                  <a:srgbClr val="7E948F"/>
+                </a:solidFill>
+                <a:latin typeface="Calibri" pitchFamily="34" charset="0"/>
+                <a:ea typeface="Calibri" pitchFamily="34" charset="-122"/>
+                <a:cs typeface="Calibri" pitchFamily="34" charset="-120"/>
+              </a:rPr>
+              <a:t>eth.blockid.au</a:t>
+            </a:r>
+            <a:endParaRPr lang="en-US" sz="850" dirty="0"/>
+          </a:p>
+        </p:txBody>
+      </p:sp>
+      <p:pic>
+        <p:nvPicPr>
+          <p:cNvPr id="33" name="Image 2" descr="preencoded.png">    </p:cNvPr>
+          <p:cNvPicPr>
+            <a:picLocks noChangeAspect="1"/>
+          </p:cNvPicPr>
+          <p:nvPr/>
+        </p:nvPicPr>
+        <p:blipFill>
+          <a:blip r:embed="rId3"/>
+          <a:stretch>
+            <a:fillRect/>
+          </a:stretch>
+        </p:blipFill>
+        <p:spPr>
+          <a:xfrm>
+            <a:off x="10241280" y="1783080"/>
+            <a:ext cx="1280160" cy="1280160"/>
+          </a:xfrm>
+          <a:prstGeom prst="rect">
+            <a:avLst/>
+          </a:prstGeom>
+        </p:spPr>
+      </p:pic>
+      <p:sp>
+        <p:nvSpPr>
+          <p:cNvPr id="34" name="Text 29"/>
+          <p:cNvSpPr txBox="1"/>
+          <p:nvPr/>
+        </p:nvSpPr>
+        <p:spPr>
+          <a:xfrm>
+            <a:off x="10241280" y="3108960"/>
+            <a:ext cx="1280160" cy="256032"/>
+          </a:xfrm>
+          <a:prstGeom prst="rect">
+            <a:avLst/>
+          </a:prstGeom>
+          <a:noFill/>
+          <a:ln/>
+        </p:spPr>
+        <p:txBody>
+          <a:bodyPr wrap="square" lIns="0" tIns="0" rIns="0" bIns="0" rtlCol="0" anchor="ctr"/>
+          <a:lstStyle/>
+          <a:p>
+            <a:pPr algn="ctr" indent="0" marL="0">
+              <a:buNone/>
+            </a:pPr>
+            <a:r>
+              <a:rPr lang="en-US" sz="1050" b="1" dirty="0">
+                <a:solidFill>
+                  <a:srgbClr val="E3A83A"/>
+                </a:solidFill>
+                <a:latin typeface="Calibri" pitchFamily="34" charset="0"/>
+                <a:ea typeface="Calibri" pitchFamily="34" charset="-122"/>
+                <a:cs typeface="Calibri" pitchFamily="34" charset="-120"/>
+              </a:rPr>
+              <a:t>LinkedIn</a:t>
+            </a:r>
+            <a:endParaRPr lang="en-US" sz="1050" dirty="0"/>
+          </a:p>
+        </p:txBody>
+      </p:sp>
+      <p:sp>
+        <p:nvSpPr>
+          <p:cNvPr id="35" name="Text 30"/>
+          <p:cNvSpPr txBox="1"/>
+          <p:nvPr/>
+        </p:nvSpPr>
+        <p:spPr>
+          <a:xfrm>
+            <a:off x="10241280" y="3337560"/>
+            <a:ext cx="1280160" cy="228600"/>
+          </a:xfrm>
+          <a:prstGeom prst="rect">
+            <a:avLst/>
+          </a:prstGeom>
+          <a:noFill/>
+          <a:ln/>
+        </p:spPr>
+        <p:txBody>
+          <a:bodyPr wrap="square" lIns="0" tIns="0" rIns="0" bIns="0" rtlCol="0" anchor="ctr"/>
+          <a:lstStyle/>
+          <a:p>
+            <a:pPr algn="ctr" indent="0" marL="0">
+              <a:buNone/>
+            </a:pPr>
+            <a:r>
+              <a:rPr lang="en-US" sz="850" dirty="0">
+                <a:solidFill>
+                  <a:srgbClr val="7E948F"/>
+                </a:solidFill>
+                <a:latin typeface="Calibri" pitchFamily="34" charset="0"/>
+                <a:ea typeface="Calibri" pitchFamily="34" charset="-122"/>
+                <a:cs typeface="Calibri" pitchFamily="34" charset="-120"/>
+              </a:rPr>
+              <a:t>Long Do</a:t>
+            </a:r>
+            <a:endParaRPr lang="en-US" sz="850" dirty="0"/>
+          </a:p>
+        </p:txBody>
+      </p:sp>
+      <p:sp>
+        <p:nvSpPr>
+          <p:cNvPr id="36" name="Text 31"/>
+          <p:cNvSpPr txBox="1"/>
+          <p:nvPr/>
+        </p:nvSpPr>
+        <p:spPr>
+          <a:xfrm>
+            <a:off x="8686800" y="3703320"/>
+            <a:ext cx="2880360" cy="365760"/>
+          </a:xfrm>
+          <a:prstGeom prst="rect">
+            <a:avLst/>
+          </a:prstGeom>
+          <a:noFill/>
+          <a:ln/>
+        </p:spPr>
+        <p:txBody>
+          <a:bodyPr wrap="square" lIns="0" tIns="0" rIns="0" bIns="0" rtlCol="0" anchor="ctr"/>
+          <a:lstStyle/>
+          <a:p>
+            <a:pPr algn="ctr" indent="0" marL="0">
+              <a:buNone/>
+            </a:pPr>
+            <a:r>
+              <a:rPr lang="en-US" sz="1800" b="1" dirty="0">
                 <a:solidFill>
                   <a:srgbClr val="F2F7F5"/>
                 </a:solidFill>
@@ -7562,22 +7742,22 @@
                 <a:ea typeface="Arial" pitchFamily="34" charset="-122"/>
                 <a:cs typeface="Arial" pitchFamily="34" charset="-120"/>
               </a:rPr>
-              <a:t>Try it now</a:t>
-            </a:r>
-            <a:endParaRPr lang="en-US" sz="2000" dirty="0"/>
-          </a:p>
-        </p:txBody>
-      </p:sp>
-      <p:sp>
-        <p:nvSpPr>
-          <p:cNvPr id="32" name="Text 28"/>
-          <p:cNvSpPr txBox="1"/>
-          <p:nvPr/>
-        </p:nvSpPr>
-        <p:spPr>
-          <a:xfrm>
-            <a:off x="8686800" y="4160520"/>
-            <a:ext cx="2880360" cy="320040"/>
+              <a:t>Try it &amp; Connect</a:t>
+            </a:r>
+            <a:endParaRPr lang="en-US" sz="1800" dirty="0"/>
+          </a:p>
+        </p:txBody>
+      </p:sp>
+      <p:sp>
+        <p:nvSpPr>
+          <p:cNvPr id="37" name="Text 32"/>
+          <p:cNvSpPr txBox="1"/>
+          <p:nvPr/>
+        </p:nvSpPr>
+        <p:spPr>
+          <a:xfrm>
+            <a:off x="8732520" y="4160520"/>
+            <a:ext cx="2788920" cy="685800"/>
           </a:xfrm>
           <a:prstGeom prst="rect">
             <a:avLst/>
@@ -7593,30 +7773,30 @@
               <a:buNone/>
             </a:pPr>
             <a:r>
-              <a:rPr lang="en-US" sz="1400" b="1" dirty="0">
-                <a:solidFill>
-                  <a:srgbClr val="22A07F"/>
+              <a:rPr lang="en-US" sz="1200" dirty="0">
+                <a:solidFill>
+                  <a:srgbClr val="F2F7F5"/>
                 </a:solidFill>
                 <a:latin typeface="Calibri" pitchFamily="34" charset="0"/>
                 <a:ea typeface="Calibri" pitchFamily="34" charset="-122"/>
                 <a:cs typeface="Calibri" pitchFamily="34" charset="-120"/>
               </a:rPr>
-              <a:t>eth.blockid.au</a:t>
-            </a:r>
-            <a:endParaRPr lang="en-US" sz="1400" dirty="0"/>
-          </a:p>
-        </p:txBody>
-      </p:sp>
-      <p:sp>
-        <p:nvSpPr>
-          <p:cNvPr id="33" name="Text 29"/>
-          <p:cNvSpPr txBox="1"/>
-          <p:nvPr/>
-        </p:nvSpPr>
-        <p:spPr>
-          <a:xfrm>
-            <a:off x="8732520" y="4617720"/>
-            <a:ext cx="2788920" cy="731520"/>
+              <a:t>Looking for: pilot startups, accelerators, licensed partners</a:t>
+            </a:r>
+            <a:endParaRPr lang="en-US" sz="1200" dirty="0"/>
+          </a:p>
+        </p:txBody>
+      </p:sp>
+      <p:sp>
+        <p:nvSpPr>
+          <p:cNvPr id="38" name="Text 33"/>
+          <p:cNvSpPr txBox="1"/>
+          <p:nvPr/>
+        </p:nvSpPr>
+        <p:spPr>
+          <a:xfrm>
+            <a:off x="8686800" y="5166360"/>
+            <a:ext cx="2880360" cy="292608"/>
           </a:xfrm>
           <a:prstGeom prst="rect">
             <a:avLst/>
@@ -7632,29 +7812,29 @@
               <a:buNone/>
             </a:pPr>
             <a:r>
-              <a:rPr lang="en-US" sz="1250" dirty="0">
-                <a:solidFill>
-                  <a:srgbClr val="F2F7F5"/>
+              <a:rPr lang="en-US" sz="1200" dirty="0">
+                <a:solidFill>
+                  <a:srgbClr val="A9BDB7"/>
                 </a:solidFill>
                 <a:latin typeface="Calibri" pitchFamily="34" charset="0"/>
                 <a:ea typeface="Calibri" pitchFamily="34" charset="-122"/>
                 <a:cs typeface="Calibri" pitchFamily="34" charset="-120"/>
               </a:rPr>
-              <a:t>Looking for: pilot startups, accelerators, licensed partners</a:t>
-            </a:r>
-            <a:endParaRPr lang="en-US" sz="1250" dirty="0"/>
-          </a:p>
-        </p:txBody>
-      </p:sp>
-      <p:sp>
-        <p:nvSpPr>
-          <p:cNvPr id="34" name="Text 30"/>
-          <p:cNvSpPr txBox="1"/>
-          <p:nvPr/>
-        </p:nvSpPr>
-        <p:spPr>
-          <a:xfrm>
-            <a:off x="8686800" y="5440680"/>
+              <a:t>Long Do · long@blockid.au</a:t>
+            </a:r>
+            <a:endParaRPr lang="en-US" sz="1200" dirty="0"/>
+          </a:p>
+        </p:txBody>
+      </p:sp>
+      <p:sp>
+        <p:nvSpPr>
+          <p:cNvPr id="39" name="Text 34"/>
+          <p:cNvSpPr txBox="1"/>
+          <p:nvPr/>
+        </p:nvSpPr>
+        <p:spPr>
+          <a:xfrm>
+            <a:off x="8686800" y="5504688"/>
             <a:ext cx="2880360" cy="292608"/>
           </a:xfrm>
           <a:prstGeom prst="rect">
@@ -7671,53 +7851,14 @@
               <a:buNone/>
             </a:pPr>
             <a:r>
-              <a:rPr lang="en-US" sz="1200" dirty="0">
-                <a:solidFill>
-                  <a:srgbClr val="A9BDB7"/>
+              <a:rPr lang="en-US" sz="1200" b="1" u="sng" dirty="0">
+                <a:solidFill>
+                  <a:srgbClr val="22A07F"/>
                 </a:solidFill>
                 <a:latin typeface="Calibri" pitchFamily="34" charset="0"/>
                 <a:ea typeface="Calibri" pitchFamily="34" charset="-122"/>
                 <a:cs typeface="Calibri" pitchFamily="34" charset="-120"/>
-              </a:rPr>
-              <a:t>Long Do · long@blockid.au</a:t>
-            </a:r>
-            <a:endParaRPr lang="en-US" sz="1200" dirty="0"/>
-          </a:p>
-        </p:txBody>
-      </p:sp>
-      <p:sp>
-        <p:nvSpPr>
-          <p:cNvPr id="35" name="Text 31"/>
-          <p:cNvSpPr txBox="1"/>
-          <p:nvPr/>
-        </p:nvSpPr>
-        <p:spPr>
-          <a:xfrm>
-            <a:off x="8686800" y="5733288"/>
-            <a:ext cx="2880360" cy="292608"/>
-          </a:xfrm>
-          <a:prstGeom prst="rect">
-            <a:avLst/>
-          </a:prstGeom>
-          <a:noFill/>
-          <a:ln/>
-        </p:spPr>
-        <p:txBody>
-          <a:bodyPr wrap="square" lIns="0" tIns="0" rIns="0" bIns="0" rtlCol="0" anchor="ctr"/>
-          <a:lstStyle/>
-          <a:p>
-            <a:pPr algn="ctr" indent="0" marL="0">
-              <a:buNone/>
-            </a:pPr>
-            <a:r>
-              <a:rPr lang="en-US" sz="1200" b="1" u="sng" dirty="0">
-                <a:solidFill>
-                  <a:srgbClr val="22A07F"/>
-                </a:solidFill>
-                <a:latin typeface="Calibri" pitchFamily="34" charset="0"/>
-                <a:ea typeface="Calibri" pitchFamily="34" charset="-122"/>
-                <a:cs typeface="Calibri" pitchFamily="34" charset="-120"/>
-                <a:hlinkClick r:id="rId3" invalidUrl="" action="" tgtFrame="" tooltip="Long Do on LinkedIn" history="1" highlightClick="0" endSnd="0">
+                <a:hlinkClick r:id="rId4" invalidUrl="" action="" tgtFrame="" tooltip="Long Do on LinkedIn" history="1" highlightClick="0" endSnd="0">
                   <a:extLst>
                     <a:ext uri="{A12FA001-AC4F-418D-AE19-62706E023703}">
                       <ahyp:hlinkClr xmlns:ahyp="http://schemas.microsoft.com/office/drawing/2018/hyperlinkcolor" val="tx"/>
@@ -7733,7 +7874,7 @@
       </p:sp>
       <p:sp>
         <p:nvSpPr>
-          <p:cNvPr id="36" name="Text 32"/>
+          <p:cNvPr id="40" name="Text 35"/>
           <p:cNvSpPr txBox="1"/>
           <p:nvPr/>
         </p:nvSpPr>

</xml_diff>